<commit_message>
Fold user's voice edits from Keynote into both deck builders
Hero dek, section titles, and takeaways reworded per the author's edits
to the slideshow; conclusion now leads with 'Brown as an individual is a
remarkable basketball player.' Applied identically to the pptx builder
and the web deck so all three artifacts say the same thing.

Co-Authored-By: Claude Fable 5 <noreply@anthropic.com>
</commit_message>
<xml_diff>
--- a/outputs/Breaking_Down_The_Jaylen_Brown_Trade.pptx
+++ b/outputs/Breaking_Down_The_Jaylen_Brown_Trade.pptx
@@ -3290,7 +3290,7 @@
                 </a:solidFill>
                 <a:latin typeface="Calibri"/>
               </a:rPr>
-              <a:t>On July 1, 2026 Boston traded Brown to Philadelphia for Paul George and picks. This is the audit, built the day after: a neutral scorecard, the strongest evidence-based case for the trade, and every counter-argument we could find.</a:t>
+              <a:t>On July 1, 2026 Boston traded Brown to Philadelphia for Paul George and picks. This is a breakdown on why the trade might not be all bad news for Boston. In the world of "that boy tuff" and analytical basketball, this is a Celtics fan's version of this trade.</a:t>
             </a:r>
           </a:p>
         </p:txBody>
@@ -4011,7 +4011,7 @@
         <p:spPr>
           <a:xfrm>
             <a:off x="566928" y="5212080"/>
-            <a:ext cx="11064240" cy="548640"/>
+            <a:ext cx="11064240" cy="822960"/>
           </a:xfrm>
           <a:prstGeom prst="rect">
             <a:avLst/>
@@ -4039,7 +4039,7 @@
                 </a:solidFill>
                 <a:latin typeface="Calibri"/>
               </a:rPr>
-              <a:t>An argument that can't survive its own counter-evidence isn't worth presenting. </a:t>
+              <a:t>Brown as an individual is a remarkable basketball player, there is no denying that. </a:t>
             </a:r>
             <a:r>
               <a:rPr sz="1400" b="0" i="0">
@@ -4048,7 +4048,7 @@
                 </a:solidFill>
                 <a:latin typeface="Calibri"/>
               </a:rPr>
-              <a:t>Every brief in this project ships with its weakest points attached.</a:t>
+              <a:t>But he was just an expensive player that didn't quite fit what the Celtics are trying to do. The data says the best version of this team was always Tatum at the top.</a:t>
             </a:r>
           </a:p>
         </p:txBody>
@@ -4501,57 +4501,6 @@
           </a:p>
         </p:txBody>
       </p:sp>
-      <p:sp>
-        <p:nvSpPr>
-          <p:cNvPr id="10" name="TextBox 9"/>
-          <p:cNvSpPr txBox="1"/>
-          <p:nvPr/>
-        </p:nvSpPr>
-        <p:spPr>
-          <a:xfrm>
-            <a:off x="960120" y="5623560"/>
-            <a:ext cx="10424160" cy="731520"/>
-          </a:xfrm>
-          <a:prstGeom prst="rect">
-            <a:avLst/>
-          </a:prstGeom>
-          <a:noFill/>
-        </p:spPr>
-        <p:txBody>
-          <a:bodyPr wrap="square" anchor="t" lIns="0" rIns="0" tIns="0" bIns="0">
-            <a:spAutoFit/>
-          </a:bodyPr>
-          <a:lstStyle/>
-          <a:p>
-            <a:pPr algn="l">
-              <a:lnSpc>
-                <a:spcPct val="112000"/>
-              </a:lnSpc>
-              <a:spcAft>
-                <a:spcPts val="400"/>
-              </a:spcAft>
-            </a:pPr>
-            <a:r>
-              <a:rPr sz="1250" b="1" i="0">
-                <a:solidFill>
-                  <a:srgbClr val="8FA89B"/>
-                </a:solidFill>
-                <a:latin typeface="Calibri"/>
-              </a:rPr>
-              <a:t>Honesty note: </a:t>
-            </a:r>
-            <a:r>
-              <a:rPr sz="1250" b="0" i="1">
-                <a:solidFill>
-                  <a:srgbClr val="8FA89B"/>
-                </a:solidFill>
-                <a:latin typeface="Calibri"/>
-              </a:rPr>
-              <a:t>this deck argues Boston's side on purpose; the neutral scorecard, the Tatum-injury confound, and the media's pro-Philadelphia consensus are all documented in the repo.</a:t>
-            </a:r>
-          </a:p>
-        </p:txBody>
-      </p:sp>
     </p:spTree>
   </p:cSld>
   <p:clrMapOvr>
@@ -4651,13 +4600,13 @@
               </a:spcAft>
             </a:pPr>
             <a:r>
-              <a:rPr sz="3000" b="1" i="0">
+              <a:rPr sz="2700" b="1" i="0">
                 <a:solidFill>
                   <a:srgbClr val="0A2A1A"/>
                 </a:solidFill>
                 <a:latin typeface="Cambria"/>
               </a:rPr>
-              <a:t>A $53M wing, a movement-3 system, and a real trade to audit</a:t>
+              <a:t>A $53M wing that shoots long twos, and a live or die by the three pointer system</a:t>
             </a:r>
           </a:p>
         </p:txBody>
@@ -5221,7 +5170,7 @@
                 </a:solidFill>
                 <a:latin typeface="Calibri"/>
               </a:rPr>
-              <a:t>Boston's edge was a movement-3 offense with five connected players. </a:t>
+              <a:t>Boston's edge is shooting more threes than opponents. </a:t>
             </a:r>
             <a:r>
               <a:rPr sz="1500" b="0" i="0">
@@ -5230,16 +5179,7 @@
                 </a:solidFill>
                 <a:latin typeface="Calibri"/>
               </a:rPr>
-              <a:t>The question this deck answers with data: did Brown's game pull with that identity or against it — and was the return worth it? </a:t>
-            </a:r>
-            <a:r>
-              <a:rPr sz="1500" b="1" i="0">
-                <a:solidFill>
-                  <a:srgbClr val="007A33"/>
-                </a:solidFill>
-                <a:latin typeface="Calibri"/>
-              </a:rPr>
-              <a:t>Every chart comes from a reproducible, unit-tested pipeline.</a:t>
+              <a:t>The question this deck answers with data: did Brown's game pull with that identity or against it, and was the return worth it?</a:t>
             </a:r>
           </a:p>
         </p:txBody>
@@ -5739,7 +5679,7 @@
                 </a:solidFill>
                 <a:latin typeface="Calibri"/>
               </a:rPr>
-              <a:t>The xFG model (2,661 shots) scores his shot-making at expectation — ≈ +0.000 both years. The difficulty is self-inflicted.</a:t>
+              <a:t>The xFG model (2,661 shots) scores his shot-making at expectation — ≈ 0 both years. The difficulty is self-inflicted.</a:t>
             </a:r>
           </a:p>
         </p:txBody>
@@ -5781,7 +5721,7 @@
                 </a:solidFill>
                 <a:latin typeface="Calibri"/>
               </a:rPr>
-              <a:t>This is the cleanest, least-confounded number in the file: </a:t>
+              <a:t>Brown's own shot selection drifted far away from what the system is built on, </a:t>
             </a:r>
             <a:r>
               <a:rPr sz="1400" b="1" i="0">
@@ -5790,7 +5730,7 @@
                 </a:solidFill>
                 <a:latin typeface="Calibri"/>
               </a:rPr>
-              <a:t>the possession-termination profile trended away from the identity, with no shot-making bailout.</a:t>
+              <a:t>and his "tough" shot making isn't good enough to excuse it.</a:t>
             </a:r>
           </a:p>
         </p:txBody>
@@ -5951,7 +5891,7 @@
                 </a:solidFill>
                 <a:latin typeface="Cambria"/>
               </a:rPr>
-              <a:t>Boston's identity is math — and Brown was its one outlier</a:t>
+              <a:t>Boston's identity is math and Brown ruins it</a:t>
             </a:r>
           </a:p>
         </p:txBody>
@@ -6017,7 +5957,7 @@
                 </a:solidFill>
                 <a:latin typeface="Calibri"/>
               </a:rPr>
-              <a:t>#1 · #1 · #4 in three-point volume and a top-2 offense all three years — threes returned 1.10 points per shot vs 0.97 for twos. </a:t>
+              <a:t>#1 · #1 · #4 in three-point volume and a top-2 offense all three years. Threes returned 1.10 points per shot vs 0.97 for twos. </a:t>
             </a:r>
             <a:r>
               <a:rPr sz="1300" b="1" i="0">
@@ -6035,7 +5975,7 @@
                 </a:solidFill>
                 <a:latin typeface="Calibri"/>
               </a:rPr>
-              <a:t>A shot-mix problem, not a finishing one (his 1.046 PPS vs 1.101) — and honestly priced, swapping his diet for George's is roughly a wash after creation and aging discounts. The offense case supports; it doesn't headline.</a:t>
+              <a:t>A shot-mix problem, not a finishing one (his 1.046 PPS vs 1.101).</a:t>
             </a:r>
           </a:p>
         </p:txBody>
@@ -6196,7 +6136,7 @@
                 </a:solidFill>
                 <a:latin typeface="Cambria"/>
               </a:rPr>
-              <a:t>Redistribute Brown's 21.7 shots to the wings — priced honestly</a:t>
+              <a:t>Redistribute Brown's 21.7 shots to the wings</a:t>
             </a:r>
           </a:p>
         </p:txBody>
@@ -6271,7 +6211,7 @@
                 </a:solidFill>
                 <a:latin typeface="Calibri"/>
               </a:rPr>
-              <a:t>Usage-adjusted: roughly a wash (−0.7 to +0.9 wins). And the George-only 1-for-1 is negative — spreading beats concentrating. </a:t>
+              <a:t>Usage-adjusted: roughly a wash (−0.7 to +0.9 wins). And the George-only 1-for-1 is negative for the Celtics. </a:t>
             </a:r>
             <a:r>
               <a:rPr sz="1300" b="1" i="0">
@@ -6280,7 +6220,7 @@
                 </a:solidFill>
                 <a:latin typeface="Calibri"/>
               </a:rPr>
-              <a:t>The real upside isn't in this mechanical model — it's Tatum's creation (5.7-6.1 ast, .498 3PT-rate gravity) upgrading the shots these wings get, and that effect is already measured in the +11.9 Tatum-led lineups. Combined honest range: ~+4 to +8 wins — the projections overlap and do NOT stack.</a:t>
+              <a:t>The real upside is Tatum's creation (5.7-6.1 ast, .498 3PT-rate gravity) upgrading the shots these wings get, and that effect is already measured in the +11.9 Tatum-led lineups. Combined honest range: ~+4 to +8 wins (without Brown this year).</a:t>
             </a:r>
           </a:p>
         </p:txBody>
@@ -6983,7 +6923,7 @@
                 </a:solidFill>
                 <a:latin typeface="Cambria"/>
               </a:rPr>
-              <a:t>First-option Tatum beat load-sharing — on the floor and in the standings</a:t>
+              <a:t>First-option Tatum will be a problem (in a good way)</a:t>
             </a:r>
           </a:p>
         </p:txBody>
@@ -7322,7 +7262,7 @@
                 </a:solidFill>
                 <a:latin typeface="Calibri"/>
               </a:rPr>
-              <a:t>Projection, not observation: the +4.3 lineup gap, shrunk 40-60% for bench/garbage contamination → +1.7-2.6 team net → +4.7-7.0 wins. Assumptions documented in the memo.</a:t>
+              <a:t>Projection, not observation: the +4.3 lineup gap, shrunk 40-60% for bench/garbage contamination → +1.7-2.6 team net → +4.7-7.0 wins.</a:t>
             </a:r>
           </a:p>
         </p:txBody>
@@ -7373,16 +7313,7 @@
                 </a:solidFill>
                 <a:latin typeface="Calibri"/>
               </a:rPr>
-              <a:t>27.2-28.8 pts · 7.8-8.9 reb · 5.1-6.2 ast · .566-.584 TS </a:t>
-            </a:r>
-            <a:r>
-              <a:rPr sz="1300" b="0" i="0">
-                <a:solidFill>
-                  <a:srgbClr val="6B7280"/>
-                </a:solidFill>
-                <a:latin typeface="Calibri"/>
-              </a:rPr>
-              <a:t>— stated as a range from the observed 16-game sample and a documented usage-tradeoff model, because false precision is how decks lie.</a:t>
+              <a:t>27.2-28.8 pts · 7.8-8.9 reb · 5.1-6.2 ast · .566-.584 TS</a:t>
             </a:r>
           </a:p>
         </p:txBody>
@@ -7390,48 +7321,6 @@
       <p:sp>
         <p:nvSpPr>
           <p:cNvPr id="12" name="TextBox 11"/>
-          <p:cNvSpPr txBox="1"/>
-          <p:nvPr/>
-        </p:nvSpPr>
-        <p:spPr>
-          <a:xfrm>
-            <a:off x="566928" y="5989320"/>
-            <a:ext cx="11064240" cy="411480"/>
-          </a:xfrm>
-          <a:prstGeom prst="rect">
-            <a:avLst/>
-          </a:prstGeom>
-          <a:noFill/>
-        </p:spPr>
-        <p:txBody>
-          <a:bodyPr wrap="square" anchor="t" lIns="0" rIns="0" tIns="0" bIns="0">
-            <a:spAutoFit/>
-          </a:bodyPr>
-          <a:lstStyle/>
-          <a:p>
-            <a:pPr algn="l">
-              <a:lnSpc>
-                <a:spcPct val="105000"/>
-              </a:lnSpc>
-              <a:spcAft>
-                <a:spcPts val="400"/>
-              </a:spcAft>
-            </a:pPr>
-            <a:r>
-              <a:rPr sz="1150" b="0" i="1">
-                <a:solidFill>
-                  <a:srgbClr val="6B7280"/>
-                </a:solidFill>
-                <a:latin typeface="Calibri"/>
-              </a:rPr>
-              <a:t>Honesty flags: Wilson intervals on the win rates overlap — claim is 'no evidence of drop-off,' not proof. And Brown's own 7-game solo cell was the matrix's best (6-1, +15.8). See slide 10.</a:t>
-            </a:r>
-          </a:p>
-        </p:txBody>
-      </p:sp>
-      <p:sp>
-        <p:nvSpPr>
-          <p:cNvPr id="13" name="TextBox 12"/>
           <p:cNvSpPr txBox="1"/>
           <p:nvPr/>
         </p:nvSpPr>
@@ -7651,7 +7540,7 @@
                 </a:solidFill>
                 <a:latin typeface="Calibri"/>
               </a:rPr>
-              <a:t>6.9 WS on $53.1M = $7.7M per win share at 34% of the cap, with a 0.573 TS% — below the max-wing median. </a:t>
+              <a:t>6.9 WS on $53.1M = $7.7M per win share at 34% of the cap, with a 0.573 TS%, below the max-wing median. </a:t>
             </a:r>
             <a:r>
               <a:rPr sz="1400" b="1" i="0">
@@ -7815,13 +7704,13 @@
               </a:spcAft>
             </a:pPr>
             <a:r>
-              <a:rPr sz="3000" b="1" i="0">
+              <a:rPr sz="2800" b="1" i="0">
                 <a:solidFill>
                   <a:srgbClr val="0A2A1A"/>
                 </a:solidFill>
                 <a:latin typeface="Cambria"/>
               </a:rPr>
-              <a:t>George is the cleaner stylistic fit — and the picks are the point</a:t>
+              <a:t>George is the cleaner fit for the Celtics system, and new lottery odds</a:t>
             </a:r>
           </a:p>
         </p:txBody>
@@ -8667,7 +8556,7 @@
                 </a:solidFill>
                 <a:latin typeface="Calibri"/>
               </a:rPr>
-              <a:t>George takes the shots the system is built to generate — he plugs in instead of stopping it.</a:t>
+              <a:t>George takes the shots the system is built to generate. He plugs in instead of stopping it.</a:t>
             </a:r>
           </a:p>
         </p:txBody>
@@ -8858,7 +8747,7 @@
                 </a:solidFill>
                 <a:latin typeface="Calibri"/>
               </a:rPr>
-              <a:t>Under the post-2019 flattened lottery — exact odds enumerated across all 24,024 seed permutations — late-lottery firsts convey materially more top-4 equity than the old system.</a:t>
+              <a:t>Under the post-2019 flattened lottery exact odds enumerated across all 24,024 seed permutations, late-lottery firsts convey materially more top-4 equity than the old system.</a:t>
             </a:r>
           </a:p>
         </p:txBody>

</xml_diff>